<commit_message>
feat: Migrate the data warehousing, ELT, and ingestion components from DuckDB to Google BigQuery.
</commit_message>
<xml_diff>
--- a/London_Bikes_Executive_Presentation.pptx
+++ b/London_Bikes_Executive_Presentation.pptx
@@ -3086,6 +3086,14 @@
 <file path=ppt/slides/slide1.xml><?xml version="1.0" encoding="utf-8"?>
 <p:sld xmlns:a="http://schemas.openxmlformats.org/drawingml/2006/main" xmlns:p="http://schemas.openxmlformats.org/presentationml/2006/main" xmlns:r="http://schemas.openxmlformats.org/officeDocument/2006/relationships">
   <p:cSld>
+    <p:bg>
+      <p:bgPr>
+        <a:solidFill>
+          <a:srgbClr val="182B49"/>
+        </a:solidFill>
+        <a:effectLst/>
+      </p:bgPr>
+    </p:bg>
     <p:spTree>
       <p:nvGrpSpPr>
         <p:cNvPr id="1" name=""/>
@@ -3109,6 +3117,12 @@
           <a:lstStyle/>
           <a:p>
             <a:r>
+              <a:rPr sz="3600" b="1">
+                <a:solidFill>
+                  <a:srgbClr val="F2A900"/>
+                </a:solidFill>
+                <a:latin typeface="Arial"/>
+              </a:rPr>
               <a:t>London Bicycles: End-to-End Data Pipeline &amp; Strategy</a:t>
             </a:r>
           </a:p>
@@ -3130,21 +3144,45 @@
           <a:lstStyle/>
           <a:p>
             <a:r>
+              <a:rPr sz="1800">
+                <a:solidFill>
+                  <a:srgbClr val="FFFFFF"/>
+                </a:solidFill>
+                <a:latin typeface="Arial"/>
+              </a:rPr>
               <a:t>Executive Summary</a:t>
             </a:r>
           </a:p>
           <a:p>
             <a:r>
+              <a:rPr sz="1800">
+                <a:solidFill>
+                  <a:srgbClr val="FFFFFF"/>
+                </a:solidFill>
+                <a:latin typeface="Arial"/>
+              </a:rPr>
               <a:t>Problem: Opaque logistics and unpredictable demand.</a:t>
             </a:r>
           </a:p>
           <a:p>
             <a:r>
+              <a:rPr sz="1800">
+                <a:solidFill>
+                  <a:srgbClr val="FFFFFF"/>
+                </a:solidFill>
+                <a:latin typeface="Arial"/>
+              </a:rPr>
               <a:t>Solution: Automated BigQuery Pipeline &amp; Actionable BI Analytics</a:t>
             </a:r>
           </a:p>
           <a:p>
             <a:r>
+              <a:rPr sz="1800">
+                <a:solidFill>
+                  <a:srgbClr val="FFFFFF"/>
+                </a:solidFill>
+                <a:latin typeface="Arial"/>
+              </a:rPr>
               <a:t>Impact: Reduced reallocation costs and targeted revenue generation.</a:t>
             </a:r>
           </a:p>
@@ -3161,6 +3199,14 @@
 <file path=ppt/slides/slide2.xml><?xml version="1.0" encoding="utf-8"?>
 <p:sld xmlns:a="http://schemas.openxmlformats.org/drawingml/2006/main" xmlns:p="http://schemas.openxmlformats.org/presentationml/2006/main" xmlns:r="http://schemas.openxmlformats.org/officeDocument/2006/relationships">
   <p:cSld>
+    <p:bg>
+      <p:bgPr>
+        <a:solidFill>
+          <a:srgbClr val="182B49"/>
+        </a:solidFill>
+        <a:effectLst/>
+      </p:bgPr>
+    </p:bg>
     <p:spTree>
       <p:nvGrpSpPr>
         <p:cNvPr id="1" name=""/>
@@ -3184,6 +3230,12 @@
           <a:lstStyle/>
           <a:p>
             <a:r>
+              <a:rPr sz="3600" b="1">
+                <a:solidFill>
+                  <a:srgbClr val="F2A900"/>
+                </a:solidFill>
+                <a:latin typeface="Arial"/>
+              </a:rPr>
               <a:t>Business Value Proposition</a:t>
             </a:r>
           </a:p>
@@ -3205,21 +3257,45 @@
           <a:lstStyle/>
           <a:p>
             <a:r>
+              <a:rPr sz="2000">
+                <a:solidFill>
+                  <a:srgbClr val="FFFFFF"/>
+                </a:solidFill>
+                <a:latin typeface="Arial"/>
+              </a:rPr>
               <a:t>Strategic Alignment via Data</a:t>
             </a:r>
           </a:p>
           <a:p>
             <a:r>
+              <a:rPr sz="2000">
+                <a:solidFill>
+                  <a:srgbClr val="FFFFFF"/>
+                </a:solidFill>
+                <a:latin typeface="Arial"/>
+              </a:rPr>
               <a:t>- Efficiency: Automated ELT reduces manual analytics overhead by 90%.</a:t>
             </a:r>
           </a:p>
           <a:p>
             <a:r>
+              <a:rPr sz="2000">
+                <a:solidFill>
+                  <a:srgbClr val="FFFFFF"/>
+                </a:solidFill>
+                <a:latin typeface="Arial"/>
+              </a:rPr>
               <a:t>- Visibility: Unlocked clear views into hourly revenue concentration.</a:t>
             </a:r>
           </a:p>
           <a:p>
             <a:r>
+              <a:rPr sz="2000">
+                <a:solidFill>
+                  <a:srgbClr val="FFFFFF"/>
+                </a:solidFill>
+                <a:latin typeface="Arial"/>
+              </a:rPr>
               <a:t>- Growth: Data-driven insights direct targeted marketing and dynamic pricing.</a:t>
             </a:r>
           </a:p>
@@ -3236,6 +3312,14 @@
 <file path=ppt/slides/slide3.xml><?xml version="1.0" encoding="utf-8"?>
 <p:sld xmlns:a="http://schemas.openxmlformats.org/drawingml/2006/main" xmlns:p="http://schemas.openxmlformats.org/presentationml/2006/main" xmlns:r="http://schemas.openxmlformats.org/officeDocument/2006/relationships">
   <p:cSld>
+    <p:bg>
+      <p:bgPr>
+        <a:solidFill>
+          <a:srgbClr val="182B49"/>
+        </a:solidFill>
+        <a:effectLst/>
+      </p:bgPr>
+    </p:bg>
     <p:spTree>
       <p:nvGrpSpPr>
         <p:cNvPr id="1" name=""/>
@@ -3259,6 +3343,12 @@
           <a:lstStyle/>
           <a:p>
             <a:r>
+              <a:rPr sz="3600" b="1">
+                <a:solidFill>
+                  <a:srgbClr val="F2A900"/>
+                </a:solidFill>
+                <a:latin typeface="Arial"/>
+              </a:rPr>
               <a:t>Key Findings &amp; Actionable Insights</a:t>
             </a:r>
           </a:p>
@@ -3281,21 +3371,45 @@
           <a:p/>
           <a:p>
             <a:r>
+              <a:rPr sz="1600">
+                <a:solidFill>
+                  <a:srgbClr val="FFFFFF"/>
+                </a:solidFill>
+                <a:latin typeface="Arial"/>
+              </a:rPr>
               <a:t>1) Revenue Is Dangerously Seasonal (Operations scale down required in winter)</a:t>
             </a:r>
           </a:p>
           <a:p>
             <a:r>
+              <a:rPr sz="1600">
+                <a:solidFill>
+                  <a:srgbClr val="FFFFFF"/>
+                </a:solidFill>
+                <a:latin typeface="Arial"/>
+              </a:rPr>
               <a:t>2) Revenue Opportunity Is Concentrated Hourly (Dynamic pricing highly effective at 8am &amp; 5pm)</a:t>
             </a:r>
           </a:p>
           <a:p>
             <a:r>
+              <a:rPr sz="1600">
+                <a:solidFill>
+                  <a:srgbClr val="FFFFFF"/>
+                </a:solidFill>
+                <a:latin typeface="Arial"/>
+              </a:rPr>
               <a:t>3) Demand Spikes Are Invisible Until Too Late (Predictive ML models urgently needed to prevent stockouts)</a:t>
             </a:r>
           </a:p>
           <a:p>
             <a:r>
+              <a:rPr sz="1600">
+                <a:solidFill>
+                  <a:srgbClr val="FFFFFF"/>
+                </a:solidFill>
+                <a:latin typeface="Arial"/>
+              </a:rPr>
               <a:t>4) Key Volume Is Concentrated in Few Stations (Focus maintenance budgets strictly on Top 10 High Volume Hubs)</a:t>
             </a:r>
           </a:p>
@@ -3312,6 +3426,14 @@
 <file path=ppt/slides/slide4.xml><?xml version="1.0" encoding="utf-8"?>
 <p:sld xmlns:a="http://schemas.openxmlformats.org/drawingml/2006/main" xmlns:p="http://schemas.openxmlformats.org/presentationml/2006/main" xmlns:r="http://schemas.openxmlformats.org/officeDocument/2006/relationships">
   <p:cSld>
+    <p:bg>
+      <p:bgPr>
+        <a:solidFill>
+          <a:srgbClr val="182B49"/>
+        </a:solidFill>
+        <a:effectLst/>
+      </p:bgPr>
+    </p:bg>
     <p:spTree>
       <p:nvGrpSpPr>
         <p:cNvPr id="1" name=""/>
@@ -3335,6 +3457,12 @@
           <a:lstStyle/>
           <a:p>
             <a:r>
+              <a:rPr sz="3600" b="1">
+                <a:solidFill>
+                  <a:srgbClr val="F2A900"/>
+                </a:solidFill>
+                <a:latin typeface="Arial"/>
+              </a:rPr>
               <a:t>Technical Solution Overview</a:t>
             </a:r>
           </a:p>
@@ -3357,21 +3485,45 @@
           <a:p/>
           <a:p>
             <a:r>
+              <a:rPr sz="2000">
+                <a:solidFill>
+                  <a:srgbClr val="FFFFFF"/>
+                </a:solidFill>
+                <a:latin typeface="Arial"/>
+              </a:rPr>
               <a:t>- Source: Google BigQuery Public Datasets</a:t>
             </a:r>
           </a:p>
           <a:p>
             <a:r>
+              <a:rPr sz="2000">
+                <a:solidFill>
+                  <a:srgbClr val="FFFFFF"/>
+                </a:solidFill>
+                <a:latin typeface="Arial"/>
+              </a:rPr>
               <a:t>- ELT: Data Transformed using dbt architecture &amp; Python scheduling</a:t>
             </a:r>
           </a:p>
           <a:p>
             <a:r>
+              <a:rPr sz="2000">
+                <a:solidFill>
+                  <a:srgbClr val="FFFFFF"/>
+                </a:solidFill>
+                <a:latin typeface="Arial"/>
+              </a:rPr>
               <a:t>- Warehouse: Google BigQuery (Star Schema: dim_stations, fact_trips)</a:t>
             </a:r>
           </a:p>
           <a:p>
             <a:r>
+              <a:rPr sz="2000">
+                <a:solidFill>
+                  <a:srgbClr val="FFFFFF"/>
+                </a:solidFill>
+                <a:latin typeface="Arial"/>
+              </a:rPr>
               <a:t>- Presentation: Jupyter Notebooks with Pandas &amp; SQLAlchemy</a:t>
             </a:r>
           </a:p>
@@ -3388,6 +3540,14 @@
 <file path=ppt/slides/slide5.xml><?xml version="1.0" encoding="utf-8"?>
 <p:sld xmlns:a="http://schemas.openxmlformats.org/drawingml/2006/main" xmlns:p="http://schemas.openxmlformats.org/presentationml/2006/main" xmlns:r="http://schemas.openxmlformats.org/officeDocument/2006/relationships">
   <p:cSld>
+    <p:bg>
+      <p:bgPr>
+        <a:solidFill>
+          <a:srgbClr val="182B49"/>
+        </a:solidFill>
+        <a:effectLst/>
+      </p:bgPr>
+    </p:bg>
     <p:spTree>
       <p:nvGrpSpPr>
         <p:cNvPr id="1" name=""/>
@@ -3411,6 +3571,12 @@
           <a:lstStyle/>
           <a:p>
             <a:r>
+              <a:rPr sz="3600" b="1">
+                <a:solidFill>
+                  <a:srgbClr val="F2A900"/>
+                </a:solidFill>
+                <a:latin typeface="Arial"/>
+              </a:rPr>
               <a:t>Risks and Mitigation</a:t>
             </a:r>
           </a:p>
@@ -3433,21 +3599,45 @@
           <a:p/>
           <a:p>
             <a:r>
+              <a:rPr sz="1800">
+                <a:solidFill>
+                  <a:srgbClr val="FFFFFF"/>
+                </a:solidFill>
+                <a:latin typeface="Arial"/>
+              </a:rPr>
               <a:t>Risk 1: Cloud Spending Spikes querying large Fact Tables.</a:t>
             </a:r>
           </a:p>
           <a:p>
             <a:r>
+              <a:rPr sz="1800">
+                <a:solidFill>
+                  <a:srgbClr val="FFFFFF"/>
+                </a:solidFill>
+                <a:latin typeface="Arial"/>
+              </a:rPr>
               <a:t>Mitigation: Implemented clustered Fact tables and partition-level testing.</a:t>
             </a:r>
           </a:p>
           <a:p>
             <a:r>
+              <a:rPr sz="1800">
+                <a:solidFill>
+                  <a:srgbClr val="FFFFFF"/>
+                </a:solidFill>
+                <a:latin typeface="Arial"/>
+              </a:rPr>
               <a:t>Risk 2: Breaking upstream schema changes.</a:t>
             </a:r>
           </a:p>
           <a:p>
             <a:r>
+              <a:rPr sz="1800">
+                <a:solidFill>
+                  <a:srgbClr val="FFFFFF"/>
+                </a:solidFill>
+                <a:latin typeface="Arial"/>
+              </a:rPr>
               <a:t>Mitigation: Daily execution of automated Data Quality assertions (Nulls/Referential).</a:t>
             </a:r>
           </a:p>
@@ -3464,6 +3654,14 @@
 <file path=ppt/slides/slide6.xml><?xml version="1.0" encoding="utf-8"?>
 <p:sld xmlns:a="http://schemas.openxmlformats.org/drawingml/2006/main" xmlns:p="http://schemas.openxmlformats.org/presentationml/2006/main" xmlns:r="http://schemas.openxmlformats.org/officeDocument/2006/relationships">
   <p:cSld>
+    <p:bg>
+      <p:bgPr>
+        <a:solidFill>
+          <a:srgbClr val="182B49"/>
+        </a:solidFill>
+        <a:effectLst/>
+      </p:bgPr>
+    </p:bg>
     <p:spTree>
       <p:nvGrpSpPr>
         <p:cNvPr id="1" name=""/>
@@ -3487,6 +3685,12 @@
           <a:lstStyle/>
           <a:p>
             <a:r>
+              <a:rPr sz="3600" b="1">
+                <a:solidFill>
+                  <a:srgbClr val="F2A900"/>
+                </a:solidFill>
+                <a:latin typeface="Arial"/>
+              </a:rPr>
               <a:t>Q &amp; A</a:t>
             </a:r>
           </a:p>
@@ -3508,12 +3712,24 @@
           <a:lstStyle/>
           <a:p>
             <a:r>
+              <a:rPr sz="2400">
+                <a:solidFill>
+                  <a:srgbClr val="FFFFFF"/>
+                </a:solidFill>
+                <a:latin typeface="Arial"/>
+              </a:rPr>
               <a:t>Thank you for joining the London Bikes Analytics revolution.</a:t>
             </a:r>
           </a:p>
           <a:p/>
           <a:p>
             <a:r>
+              <a:rPr sz="2400">
+                <a:solidFill>
+                  <a:srgbClr val="FFFFFF"/>
+                </a:solidFill>
+                <a:latin typeface="Arial"/>
+              </a:rPr>
               <a:t>Questions?</a:t>
             </a:r>
           </a:p>

</xml_diff>